<commit_message>
Level 5 Lesson 10 draft listening audio (2:11)
</commit_message>
<xml_diff>
--- a/level5/slides/Level5_Lesson10_Slides.pptx
+++ b/level5/slides/Level5_Lesson10_Slides.pptx
@@ -8,32 +8,32 @@
     <p:notesMasterId r:id="rId22"/>
   </p:notesMasterIdLst>
   <p:sldIdLst>
-    <p:sldId id="939" r:id="rId33"/>
-    <p:sldId id="940" r:id="rId34"/>
-    <p:sldId id="941" r:id="rId35"/>
-    <p:sldId id="942" r:id="rId36"/>
-    <p:sldId id="943" r:id="rId31"/>
-    <p:sldId id="944" r:id="rId30"/>
-    <p:sldId id="945" r:id="rId29"/>
-    <p:sldId id="946" r:id="rId28"/>
-    <p:sldId id="947" r:id="rId27"/>
-    <p:sldId id="948" r:id="rId20"/>
-    <p:sldId id="949" r:id="rId18"/>
-    <p:sldId id="950" r:id="rId17"/>
-    <p:sldId id="951" r:id="rId16"/>
-    <p:sldId id="952" r:id="rId14"/>
-    <p:sldId id="953" r:id="rId13"/>
-    <p:sldId id="954" r:id="rId12"/>
-    <p:sldId id="955" r:id="rId11"/>
-    <p:sldId id="956" r:id="rId10"/>
-    <p:sldId id="957" r:id="rId8"/>
-    <p:sldId id="958" r:id="rId7"/>
-    <p:sldId id="959" r:id="rId6"/>
-    <p:sldId id="960" r:id="rId5"/>
-    <p:sldId id="961" r:id="rId4"/>
-    <p:sldId id="962" r:id="rId3"/>
-    <p:sldId id="963" r:id="rId57"/>
-    <p:sldId id="964" r:id="rId2"/>
+    <p:sldId id="1043" r:id="rId33"/>
+    <p:sldId id="1044" r:id="rId34"/>
+    <p:sldId id="1045" r:id="rId35"/>
+    <p:sldId id="1046" r:id="rId36"/>
+    <p:sldId id="1047" r:id="rId31"/>
+    <p:sldId id="1048" r:id="rId30"/>
+    <p:sldId id="1049" r:id="rId29"/>
+    <p:sldId id="1050" r:id="rId28"/>
+    <p:sldId id="1051" r:id="rId27"/>
+    <p:sldId id="1052" r:id="rId20"/>
+    <p:sldId id="1053" r:id="rId18"/>
+    <p:sldId id="1054" r:id="rId17"/>
+    <p:sldId id="1055" r:id="rId16"/>
+    <p:sldId id="1056" r:id="rId14"/>
+    <p:sldId id="1057" r:id="rId13"/>
+    <p:sldId id="1058" r:id="rId12"/>
+    <p:sldId id="1059" r:id="rId11"/>
+    <p:sldId id="1060" r:id="rId10"/>
+    <p:sldId id="1061" r:id="rId8"/>
+    <p:sldId id="1062" r:id="rId7"/>
+    <p:sldId id="1063" r:id="rId6"/>
+    <p:sldId id="1064" r:id="rId5"/>
+    <p:sldId id="1065" r:id="rId4"/>
+    <p:sldId id="1066" r:id="rId3"/>
+    <p:sldId id="1067" r:id="rId57"/>
+    <p:sldId id="1068" r:id="rId2"/>
   </p:sldIdLst>
   <p:sldSz cx="12192000" cy="6858000"/>
   <p:notesSz cx="6858000" cy="12192000"/>
@@ -536,7 +536,7 @@
           </a:p>
           <a:p>
             <a:r>
-              <a:t>Audio: the listening audio for this lesson (about 2:30) is coming soon. It will use computer-generated voices (Chatterbox TTS cloned from synthetic Kokoro-82M reference clips); no recordings of real people. Until it is ready, read the listening script (in the notes of the Before You Listen slide) with a volunteer. The names and the story are invented.</a:t>
+              <a:t>Audio: synthetic voices, computer-generated (Chatterbox TTS cloned from Kokoro-82M reference clips). No recordings of real people. The names and the story are invented.</a:t>
             </a:r>
           </a:p>
           <a:p>
@@ -1417,106 +1417,6 @@
           <a:p>
             <a:r>
               <a:t>Picture: Twemoji graphics by Twitter, Inc. and other contributors (https://github.com/jdecked/twemoji), CC BY 4.0 (https://creativecommons.org/licenses/by/4.0/); resized and combined, with signs and labels (images/CREDITS.md).</a:t>
-            </a:r>
-          </a:p>
-          <a:p>
-            <a:r>
-              <a:t>Listening script (the audio is coming soon; until then, read it aloud with a volunteer at a normal, friendly speed):</a:t>
-            </a:r>
-          </a:p>
-          <a:p>
-            <a:r>
-              <a:t>Narrator: Lesson ten. Camila and Jon share a Saturday job. They both want the day off. Ms. Nguyen asks them to work it out before she calls the shift off.</a:t>
-            </a:r>
-          </a:p>
-          <a:p>
-            <a:r>
-              <a:t>Ms. Nguyen: I don't want to call the shift off. The week was so busy that we need Saturday. Please meet in the middle.</a:t>
-            </a:r>
-          </a:p>
-          <a:p>
-            <a:r>
-              <a:t>Camila: I want to take the morning off. I have a class, and that class is my priority.</a:t>
-            </a:r>
-          </a:p>
-          <a:p>
-            <a:r>
-              <a:t>Jon: I hear you. I have a family visit in the afternoon. I was going to ask for the whole day too.</a:t>
-            </a:r>
-          </a:p>
-          <a:p>
-            <a:r>
-              <a:t>Ms. Nguyen: Say the other person's idea before you offer yours.</a:t>
-            </a:r>
-          </a:p>
-          <a:p>
-            <a:r>
-              <a:t>Camila: Jon, you need the afternoon for a family visit. I need the morning for my class.</a:t>
-            </a:r>
-          </a:p>
-          <a:p>
-            <a:r>
-              <a:t>Jon: Yes. What if we split the day? I can take the morning if you take the afternoon.</a:t>
-            </a:r>
-          </a:p>
-          <a:p>
-            <a:r>
-              <a:t>Camila: That is a fair offer. My class ends at noon. What if we swap at twelve? That is my counteroffer.</a:t>
-            </a:r>
-          </a:p>
-          <a:p>
-            <a:r>
-              <a:t>Jon: Your counteroffer works. The week was so busy that we split Saturday.</a:t>
-            </a:r>
-          </a:p>
-          <a:p>
-            <a:r>
-              <a:t>Camila: And it was such a long shift that we shared it. The week is too full for one person.</a:t>
-            </a:r>
-          </a:p>
-          <a:p>
-            <a:r>
-              <a:t>Jon: The visit is so important that I need the afternoon. This solution is about fairness.</a:t>
-            </a:r>
-          </a:p>
-          <a:p>
-            <a:r>
-              <a:t>Camila: My class is so important that I need the morning. We didn't give in. We found the middle.</a:t>
-            </a:r>
-          </a:p>
-          <a:p>
-            <a:r>
-              <a:t>Jon: I'll write the shared task on a sticky note and put it on the whiteboard.</a:t>
-            </a:r>
-          </a:p>
-          <a:p>
-            <a:r>
-              <a:t>Camila: We each get a break time. I'm going to come in at noon.</a:t>
-            </a:r>
-          </a:p>
-          <a:p>
-            <a:r>
-              <a:t>Ms. Nguyen: Read the compromise, please. I want to hear it.</a:t>
-            </a:r>
-          </a:p>
-          <a:p>
-            <a:r>
-              <a:t>Jon: I'm going to work the morning. Camila is going to work the afternoon. We swap at twelve.</a:t>
-            </a:r>
-          </a:p>
-          <a:p>
-            <a:r>
-              <a:t>Camila: Noon is such a clear time that nobody has to guess.</a:t>
-            </a:r>
-          </a:p>
-          <a:p>
-            <a:r>
-              <a:t>Ms. Nguyen: You worked it out. I'm not going to call it off. Thank you for the compromise.</a:t>
-            </a:r>
-          </a:p>
-          <a:p>
-            <a:r>
-              <a:t>Narrator: That's the end of the listening.</a:t>
             </a:r>
           </a:p>
         </p:txBody>
@@ -10502,7 +10402,7 @@
                 <a:ea typeface="Lexend Deca" pitchFamily="34" charset="-122"/>
                 <a:cs typeface="Lexend Deca" pitchFamily="34" charset="-120"/>
               </a:rPr>
-              <a:t>Audio (about 2:30): coming soon.</a:t>
+              <a:t>Audio: about 2:11. It plays once.</a:t>
             </a:r>
             <a:endParaRPr lang="en-US" sz="2200" dirty="0"/>
           </a:p>
@@ -29481,7 +29381,7 @@
                 <a:ea typeface="Lexend Deca" pitchFamily="34" charset="-122"/>
                 <a:cs typeface="Lexend Deca" pitchFamily="34" charset="-120"/>
               </a:rPr>
-              <a:t>Audio (coming soon): synthetic voices made with Chatterbox TTS (MIT License), cloned from short synthetic reference clips made with Kokoro-82M (Apache License 2.0). No recordings of real people. Each file will carry an inaudible Perth watermark marking it as AI-generated. Font: Lexend Deca (OFL 1.1).</a:t>
+              <a:t>Audio: synthetic voices made with Chatterbox TTS (MIT License), cloned from short synthetic reference clips made with Kokoro-82M (Apache License 2.0). No recordings of real people were used. Each file carries an inaudible Perth watermark marking it as AI-generated. Font: Lexend Deca (OFL 1.1).</a:t>
             </a:r>
             <a:endParaRPr lang="en-US" sz="1350" dirty="0" b="0"/>
           </a:p>

</xml_diff>